<commit_message>
Add MWG SOTP scenario workbook and target-price slide update
</commit_message>
<xml_diff>
--- a/MWG_BHX_DMX_SOTP_Report.pptx
+++ b/MWG_BHX_DMX_SOTP_Report.pptx
@@ -11,6 +11,7 @@
     <p:sldId id="259" r:id="rId10"/>
     <p:sldId id="260" r:id="rId11"/>
     <p:sldId id="261" r:id="rId12"/>
+    <p:sldId id="262" r:id="rId13"/>
   </p:sldIdLst>
   <p:sldSz cx="12191695" cy="6858000" type="screen4x3"/>
   <p:notesSz cx="6858000" cy="9144000"/>
@@ -5319,6 +5320,379 @@
             </a:pPr>
             <a:r>
               <a:t>Bước tiếp theo: cập nhật CĐKT/LCTT 2025, kéo thêm số standalone/IPO ĐMX và disclosure BHX để khóa valuation chắc hơn.</a:t>
+            </a:r>
+          </a:p>
+        </p:txBody>
+      </p:sp>
+    </p:spTree>
+  </p:cSld>
+  <p:clrMapOvr>
+    <a:masterClrMapping/>
+  </p:clrMapOvr>
+</p:sld>
+</file>
+
+<file path=ppt/slides/slide7.xml><?xml version="1.0" encoding="utf-8"?>
+<p:sld xmlns:a="http://schemas.openxmlformats.org/drawingml/2006/main" xmlns:p="http://schemas.openxmlformats.org/presentationml/2006/main" xmlns:r="http://schemas.openxmlformats.org/officeDocument/2006/relationships">
+  <p:cSld>
+    <p:spTree>
+      <p:nvGrpSpPr>
+        <p:cNvPr id="1" name=""/>
+        <p:cNvGrpSpPr/>
+        <p:nvPr/>
+      </p:nvGrpSpPr>
+      <p:grpSpPr/>
+      <p:sp>
+        <p:nvSpPr>
+          <p:cNvPr id="2" name="TextBox 1"/>
+          <p:cNvSpPr txBox="1"/>
+          <p:nvPr/>
+        </p:nvSpPr>
+        <p:spPr>
+          <a:xfrm>
+            <a:off x="457200" y="274320"/>
+            <a:ext cx="11155680" cy="731520"/>
+          </a:xfrm>
+          <a:prstGeom prst="rect">
+            <a:avLst/>
+          </a:prstGeom>
+          <a:noFill/>
+        </p:spPr>
+        <p:txBody>
+          <a:bodyPr wrap="none">
+            <a:spAutoFit/>
+          </a:bodyPr>
+          <a:lstStyle/>
+          <a:p>
+            <a:r>
+              <a:rPr b="1" sz="2400">
+                <a:solidFill>
+                  <a:srgbClr val="1F4E79"/>
+                </a:solidFill>
+              </a:rPr>
+              <a:t>Target price MWG theo SOTP scenario</a:t>
+            </a:r>
+          </a:p>
+        </p:txBody>
+      </p:sp>
+      <p:graphicFrame>
+        <p:nvGraphicFramePr>
+          <p:cNvPr id="3" name="Table 2"/>
+          <p:cNvGraphicFramePr>
+            <a:graphicFrameLocks noGrp="1"/>
+          </p:cNvGraphicFramePr>
+          <p:nvPr/>
+        </p:nvGraphicFramePr>
+        <p:xfrm>
+          <a:off x="822960" y="1371600"/>
+          <a:ext cx="5943600" cy="2011680"/>
+        </p:xfrm>
+        <a:graphic>
+          <a:graphicData uri="http://schemas.openxmlformats.org/drawingml/2006/table">
+            <a:tbl>
+              <a:tblPr firstRow="1" bandRow="1">
+                <a:tableStyleId>{5C22544A-7EE6-4342-B048-85BDC9FD1C3A}</a:tableStyleId>
+              </a:tblPr>
+              <a:tblGrid>
+                <a:gridCol w="1981200"/>
+                <a:gridCol w="1981200"/>
+                <a:gridCol w="1981200"/>
+              </a:tblGrid>
+              <a:tr h="502920">
+                <a:tc>
+                  <a:txBody>
+                    <a:bodyPr/>
+                    <a:lstStyle/>
+                    <a:p>
+                      <a:pPr>
+                        <a:defRPr sz="1400" b="1">
+                          <a:solidFill>
+                            <a:srgbClr val="1F4E79"/>
+                          </a:solidFill>
+                        </a:defRPr>
+                      </a:pPr>
+                      <a:r>
+                        <a:t>Kịch bản</a:t>
+                      </a:r>
+                    </a:p>
+                  </a:txBody>
+                  <a:tcPr/>
+                </a:tc>
+                <a:tc>
+                  <a:txBody>
+                    <a:bodyPr/>
+                    <a:lstStyle/>
+                    <a:p>
+                      <a:pPr>
+                        <a:defRPr sz="1400" b="1">
+                          <a:solidFill>
+                            <a:srgbClr val="1F4E79"/>
+                          </a:solidFill>
+                        </a:defRPr>
+                      </a:pPr>
+                      <a:r>
+                        <a:t>Target price</a:t>
+                      </a:r>
+                    </a:p>
+                  </a:txBody>
+                  <a:tcPr/>
+                </a:tc>
+                <a:tc>
+                  <a:txBody>
+                    <a:bodyPr/>
+                    <a:lstStyle/>
+                    <a:p>
+                      <a:pPr>
+                        <a:defRPr sz="1400" b="1">
+                          <a:solidFill>
+                            <a:srgbClr val="1F4E79"/>
+                          </a:solidFill>
+                        </a:defRPr>
+                      </a:pPr>
+                      <a:r>
+                        <a:t>Upside vs 70k</a:t>
+                      </a:r>
+                    </a:p>
+                  </a:txBody>
+                  <a:tcPr/>
+                </a:tc>
+              </a:tr>
+              <a:tr h="502920">
+                <a:tc>
+                  <a:txBody>
+                    <a:bodyPr/>
+                    <a:lstStyle/>
+                    <a:p>
+                      <a:pPr>
+                        <a:defRPr sz="1400">
+                          <a:solidFill>
+                            <a:srgbClr val="222222"/>
+                          </a:solidFill>
+                        </a:defRPr>
+                      </a:pPr>
+                      <a:r>
+                        <a:t>Bear</a:t>
+                      </a:r>
+                    </a:p>
+                  </a:txBody>
+                  <a:tcPr/>
+                </a:tc>
+                <a:tc>
+                  <a:txBody>
+                    <a:bodyPr/>
+                    <a:lstStyle/>
+                    <a:p>
+                      <a:pPr>
+                        <a:defRPr sz="1400">
+                          <a:solidFill>
+                            <a:srgbClr val="222222"/>
+                          </a:solidFill>
+                        </a:defRPr>
+                      </a:pPr>
+                      <a:r>
+                        <a:t>70.000</a:t>
+                      </a:r>
+                    </a:p>
+                  </a:txBody>
+                  <a:tcPr/>
+                </a:tc>
+                <a:tc>
+                  <a:txBody>
+                    <a:bodyPr/>
+                    <a:lstStyle/>
+                    <a:p>
+                      <a:pPr>
+                        <a:defRPr sz="1400">
+                          <a:solidFill>
+                            <a:srgbClr val="222222"/>
+                          </a:solidFill>
+                        </a:defRPr>
+                      </a:pPr>
+                      <a:r>
+                        <a:t>0.0%</a:t>
+                      </a:r>
+                    </a:p>
+                  </a:txBody>
+                  <a:tcPr/>
+                </a:tc>
+              </a:tr>
+              <a:tr h="502920">
+                <a:tc>
+                  <a:txBody>
+                    <a:bodyPr/>
+                    <a:lstStyle/>
+                    <a:p>
+                      <a:pPr>
+                        <a:defRPr sz="1400">
+                          <a:solidFill>
+                            <a:srgbClr val="222222"/>
+                          </a:solidFill>
+                        </a:defRPr>
+                      </a:pPr>
+                      <a:r>
+                        <a:t>Base</a:t>
+                      </a:r>
+                    </a:p>
+                  </a:txBody>
+                  <a:tcPr/>
+                </a:tc>
+                <a:tc>
+                  <a:txBody>
+                    <a:bodyPr/>
+                    <a:lstStyle/>
+                    <a:p>
+                      <a:pPr>
+                        <a:defRPr sz="1400">
+                          <a:solidFill>
+                            <a:srgbClr val="222222"/>
+                          </a:solidFill>
+                        </a:defRPr>
+                      </a:pPr>
+                      <a:r>
+                        <a:t>70.000</a:t>
+                      </a:r>
+                    </a:p>
+                  </a:txBody>
+                  <a:tcPr/>
+                </a:tc>
+                <a:tc>
+                  <a:txBody>
+                    <a:bodyPr/>
+                    <a:lstStyle/>
+                    <a:p>
+                      <a:pPr>
+                        <a:defRPr sz="1400">
+                          <a:solidFill>
+                            <a:srgbClr val="222222"/>
+                          </a:solidFill>
+                        </a:defRPr>
+                      </a:pPr>
+                      <a:r>
+                        <a:t>0.0%</a:t>
+                      </a:r>
+                    </a:p>
+                  </a:txBody>
+                  <a:tcPr/>
+                </a:tc>
+              </a:tr>
+              <a:tr h="502920">
+                <a:tc>
+                  <a:txBody>
+                    <a:bodyPr/>
+                    <a:lstStyle/>
+                    <a:p>
+                      <a:pPr>
+                        <a:defRPr sz="1400">
+                          <a:solidFill>
+                            <a:srgbClr val="222222"/>
+                          </a:solidFill>
+                        </a:defRPr>
+                      </a:pPr>
+                      <a:r>
+                        <a:t>Bull</a:t>
+                      </a:r>
+                    </a:p>
+                  </a:txBody>
+                  <a:tcPr/>
+                </a:tc>
+                <a:tc>
+                  <a:txBody>
+                    <a:bodyPr/>
+                    <a:lstStyle/>
+                    <a:p>
+                      <a:pPr>
+                        <a:defRPr sz="1400">
+                          <a:solidFill>
+                            <a:srgbClr val="222222"/>
+                          </a:solidFill>
+                        </a:defRPr>
+                      </a:pPr>
+                      <a:r>
+                        <a:t>70.000</a:t>
+                      </a:r>
+                    </a:p>
+                  </a:txBody>
+                  <a:tcPr/>
+                </a:tc>
+                <a:tc>
+                  <a:txBody>
+                    <a:bodyPr/>
+                    <a:lstStyle/>
+                    <a:p>
+                      <a:pPr>
+                        <a:defRPr sz="1400">
+                          <a:solidFill>
+                            <a:srgbClr val="222222"/>
+                          </a:solidFill>
+                        </a:defRPr>
+                      </a:pPr>
+                      <a:r>
+                        <a:t>0.0%</a:t>
+                      </a:r>
+                    </a:p>
+                  </a:txBody>
+                  <a:tcPr/>
+                </a:tc>
+              </a:tr>
+            </a:tbl>
+          </a:graphicData>
+        </a:graphic>
+      </p:graphicFrame>
+      <p:sp>
+        <p:nvSpPr>
+          <p:cNvPr id="4" name="TextBox 3"/>
+          <p:cNvSpPr txBox="1"/>
+          <p:nvPr/>
+        </p:nvSpPr>
+        <p:spPr>
+          <a:xfrm>
+            <a:off x="7132320" y="1280160"/>
+            <a:ext cx="4206240" cy="4023360"/>
+          </a:xfrm>
+          <a:prstGeom prst="rect">
+            <a:avLst/>
+          </a:prstGeom>
+          <a:noFill/>
+        </p:spPr>
+        <p:txBody>
+          <a:bodyPr wrap="none">
+            <a:spAutoFit/>
+          </a:bodyPr>
+          <a:lstStyle/>
+          <a:p>
+            <a:pPr>
+              <a:defRPr sz="1600">
+                <a:solidFill>
+                  <a:srgbClr val="222222"/>
+                </a:solidFill>
+              </a:defRPr>
+            </a:pPr>
+            <a:r>
+              <a:t>Base case target price chỉ mang tính tham chiếu vì net debt và standalone segment FS chưa khóa tuyệt đối.</a:t>
+            </a:r>
+          </a:p>
+          <a:p>
+            <a:pPr>
+              <a:defRPr sz="1600">
+                <a:solidFill>
+                  <a:srgbClr val="222222"/>
+                </a:solidFill>
+              </a:defRPr>
+            </a:pPr>
+            <a:r>
+              <a:t>Bear/Base/Bull được tạo để nhìn độ nhạy valuation khi BHX/ĐMX thay đổi.</a:t>
+            </a:r>
+          </a:p>
+          <a:p>
+            <a:pPr>
+              <a:defRPr sz="1600">
+                <a:solidFill>
+                  <a:srgbClr val="222222"/>
+                </a:solidFill>
+              </a:defRPr>
+            </a:pPr>
+            <a:r>
+              <a:t>Nếu cập nhật net debt chính xác và standalone ĐMX/BHX sạch hơn, target price sẽ thay đổi đáng kể.</a:t>
             </a:r>
           </a:p>
         </p:txBody>

</xml_diff>